<commit_message>
Entrega final: informe DIIAA + slides Demo Day + diagrama
</commit_message>
<xml_diff>
--- a/reporte/slides_demo_day.pptx
+++ b/reporte/slides_demo_day.pptx
@@ -14820,8 +14820,8 @@
         </p:blipFill>
         <p:spPr>
           <a:xfrm>
-            <a:off x="1188720" y="1463040"/>
-            <a:ext cx="9784080" cy="7560425"/>
+            <a:off x="2898648" y="1463040"/>
+            <a:ext cx="6400800" cy="4946073"/>
           </a:xfrm>
           <a:prstGeom prst="rect">
             <a:avLst/>
@@ -17502,7 +17502,7 @@
       </p:grpSpPr>
       <p:sp>
         <p:nvSpPr>
-          <p:cNvPr id="176" name="Google Shape;176;p21"/>
+          <p:cNvPr id="176" name="Rectangle 175"/>
           <p:cNvSpPr/>
           <p:nvPr/>
         </p:nvSpPr>
@@ -17520,97 +17520,67 @@
           <a:ln>
             <a:noFill/>
           </a:ln>
-          <a:effectLst>
-            <a:outerShdw blurRad="40000" rotWithShape="0" dir="5400000" dist="23000">
-              <a:srgbClr val="000000">
-                <a:alpha val="34901"/>
-              </a:srgbClr>
-            </a:outerShdw>
-          </a:effectLst>
         </p:spPr>
+        <p:style>
+          <a:lnRef idx="1">
+            <a:schemeClr val="accent1"/>
+          </a:lnRef>
+          <a:fillRef idx="3">
+            <a:schemeClr val="accent1"/>
+          </a:fillRef>
+          <a:effectRef idx="2">
+            <a:schemeClr val="accent1"/>
+          </a:effectRef>
+          <a:fontRef idx="minor">
+            <a:schemeClr val="lt1"/>
+          </a:fontRef>
+        </p:style>
         <p:txBody>
-          <a:bodyPr anchorCtr="0" anchor="ctr" bIns="45700" lIns="91425" spcFirstLastPara="1" rIns="91425" wrap="square" tIns="45700">
-            <a:noAutofit/>
-          </a:bodyPr>
+          <a:bodyPr rtlCol="0" anchor="ctr"/>
           <a:lstStyle/>
           <a:p>
-            <a:pPr indent="0" lvl="0" marL="0" marR="0" rtl="0" algn="ctr">
-              <a:spcBef>
-                <a:spcPts val="0"/>
-              </a:spcBef>
-              <a:spcAft>
-                <a:spcPts val="0"/>
-              </a:spcAft>
-              <a:buNone/>
-            </a:pPr>
-            <a:r>
-              <a:t/>
-            </a:r>
-            <a:endParaRPr b="0" i="0" sz="1800" u="none" cap="none" strike="noStrike">
-              <a:solidFill>
-                <a:schemeClr val="dk1"/>
-              </a:solidFill>
-              <a:latin typeface="Calibri"/>
-              <a:ea typeface="Calibri"/>
-              <a:cs typeface="Calibri"/>
-              <a:sym typeface="Calibri"/>
-            </a:endParaRPr>
+            <a:pPr algn="ctr"/>
           </a:p>
         </p:txBody>
       </p:sp>
       <p:sp>
         <p:nvSpPr>
-          <p:cNvPr id="177" name="Google Shape;177;p21"/>
+          <p:cNvPr id="177" name="TextBox 176"/>
           <p:cNvSpPr txBox="1"/>
           <p:nvPr/>
         </p:nvSpPr>
         <p:spPr>
           <a:xfrm>
             <a:off x="457200" y="365760"/>
-            <a:ext cx="11247000" cy="492600"/>
+            <a:ext cx="11247120" cy="731520"/>
           </a:xfrm>
           <a:prstGeom prst="rect">
             <a:avLst/>
           </a:prstGeom>
           <a:noFill/>
-          <a:ln>
-            <a:noFill/>
-          </a:ln>
         </p:spPr>
         <p:txBody>
-          <a:bodyPr anchorCtr="0" anchor="t" bIns="0" lIns="0" spcFirstLastPara="1" rIns="0" wrap="square" tIns="0">
+          <a:bodyPr wrap="square" lIns="0" rIns="0" tIns="0" bIns="0">
             <a:spAutoFit/>
           </a:bodyPr>
           <a:lstStyle/>
           <a:p>
-            <a:pPr indent="0" lvl="0" marL="0" marR="0" rtl="0" algn="l">
-              <a:spcBef>
-                <a:spcPts val="0"/>
-              </a:spcBef>
-              <a:spcAft>
-                <a:spcPts val="0"/>
-              </a:spcAft>
-              <a:buNone/>
-            </a:pPr>
+            <a:pPr algn="l"/>
             <a:r>
-              <a:rPr b="1" lang="en-US" sz="3200">
+              <a:rPr sz="3200" b="1" i="0">
                 <a:solidFill>
                   <a:srgbClr val="1F3A5F"/>
                 </a:solidFill>
                 <a:latin typeface="Calibri"/>
-                <a:ea typeface="Calibri"/>
-                <a:cs typeface="Calibri"/>
-                <a:sym typeface="Calibri"/>
               </a:rPr>
               <a:t>Ejemplo de Mail</a:t>
             </a:r>
-            <a:endParaRPr/>
           </a:p>
         </p:txBody>
       </p:sp>
       <p:sp>
         <p:nvSpPr>
-          <p:cNvPr id="178" name="Google Shape;178;p21"/>
+          <p:cNvPr id="178" name="TextBox 177"/>
           <p:cNvSpPr txBox="1"/>
           <p:nvPr/>
         </p:nvSpPr>
@@ -17623,148 +17593,109 @@
             <a:avLst/>
           </a:prstGeom>
           <a:noFill/>
-          <a:ln>
-            <a:noFill/>
-          </a:ln>
         </p:spPr>
         <p:txBody>
-          <a:bodyPr anchorCtr="0" anchor="t" bIns="0" lIns="0" spcFirstLastPara="1" rIns="0" wrap="square" tIns="0">
+          <a:bodyPr wrap="square" lIns="0" rIns="0" tIns="0" bIns="0">
             <a:spAutoFit/>
           </a:bodyPr>
           <a:lstStyle/>
           <a:p>
-            <a:pPr indent="0" lvl="0" marL="0" marR="0" rtl="0" algn="l">
-              <a:spcBef>
-                <a:spcPts val="0"/>
-              </a:spcBef>
-              <a:spcAft>
-                <a:spcPts val="0"/>
-              </a:spcAft>
-              <a:buNone/>
-            </a:pPr>
+            <a:pPr algn="l"/>
             <a:r>
-              <a:rPr b="0" i="1" lang="en-US" sz="1800" u="none" cap="none" strike="noStrike">
+              <a:rPr sz="1800" b="0" i="1">
                 <a:solidFill>
                   <a:srgbClr val="777777"/>
                 </a:solidFill>
                 <a:latin typeface="Calibri"/>
-                <a:ea typeface="Calibri"/>
-                <a:cs typeface="Calibri"/>
-                <a:sym typeface="Calibri"/>
               </a:rPr>
-              <a:t>Mail en español → análisis estructurado con citas</a:t>
+              <a:t>Un mail en español, su análisis estructurado y la respuesta lista para enviar</a:t>
             </a:r>
-            <a:endParaRPr/>
           </a:p>
         </p:txBody>
       </p:sp>
       <p:sp>
         <p:nvSpPr>
-          <p:cNvPr id="179" name="Google Shape;179;p21"/>
+          <p:cNvPr id="179" name="Rounded Rectangle 178"/>
           <p:cNvSpPr/>
           <p:nvPr/>
         </p:nvSpPr>
         <p:spPr>
           <a:xfrm>
-            <a:off x="457200" y="1828800"/>
-            <a:ext cx="5029200" cy="4114800"/>
+            <a:off x="457200" y="1691640"/>
+            <a:ext cx="5486400" cy="1828800"/>
           </a:xfrm>
           <a:prstGeom prst="roundRect">
-            <a:avLst>
-              <a:gd fmla="val 16667" name="adj"/>
-            </a:avLst>
+            <a:avLst/>
           </a:prstGeom>
           <a:solidFill>
             <a:srgbClr val="F5F5F5"/>
           </a:solidFill>
-          <a:ln cap="flat" cmpd="sng" w="9525">
+          <a:ln>
             <a:solidFill>
               <a:srgbClr val="CCCCCC"/>
             </a:solidFill>
-            <a:prstDash val="solid"/>
-            <a:round/>
-            <a:headEnd len="sm" w="sm" type="none"/>
-            <a:tailEnd len="sm" w="sm" type="none"/>
           </a:ln>
-          <a:effectLst>
-            <a:outerShdw blurRad="40000" rotWithShape="0" dir="5400000" dist="23000">
-              <a:srgbClr val="000000">
-                <a:alpha val="34901"/>
-              </a:srgbClr>
-            </a:outerShdw>
-          </a:effectLst>
         </p:spPr>
+        <p:style>
+          <a:lnRef idx="1">
+            <a:schemeClr val="accent1"/>
+          </a:lnRef>
+          <a:fillRef idx="3">
+            <a:schemeClr val="accent1"/>
+          </a:fillRef>
+          <a:effectRef idx="2">
+            <a:schemeClr val="accent1"/>
+          </a:effectRef>
+          <a:fontRef idx="minor">
+            <a:schemeClr val="lt1"/>
+          </a:fontRef>
+        </p:style>
         <p:txBody>
-          <a:bodyPr anchorCtr="0" anchor="ctr" bIns="45700" lIns="190500" spcFirstLastPara="1" rIns="91425" wrap="square" tIns="190500">
-            <a:noAutofit/>
-          </a:bodyPr>
+          <a:bodyPr rtlCol="0" anchor="ctr" lIns="190500" tIns="152400" wrap="square"/>
           <a:lstStyle/>
           <a:p>
-            <a:pPr indent="0" lvl="0" marL="0" marR="0" rtl="0" algn="ctr">
-              <a:spcBef>
-                <a:spcPts val="0"/>
-              </a:spcBef>
-              <a:spcAft>
-                <a:spcPts val="0"/>
-              </a:spcAft>
-              <a:buNone/>
-            </a:pPr>
+            <a:pPr algn="ctr"/>
             <a:r>
-              <a:rPr b="1" i="0" lang="en-US" sz="1400" u="none" cap="none" strike="noStrike">
+              <a:rPr sz="1300" b="1">
                 <a:solidFill>
                   <a:srgbClr val="777777"/>
                 </a:solidFill>
                 <a:latin typeface="Calibri"/>
-                <a:ea typeface="Calibri"/>
-                <a:cs typeface="Calibri"/>
-                <a:sym typeface="Calibri"/>
               </a:rPr>
-              <a:t>Mail del cliente</a:t>
+              <a:t>📩 Mail del cliente</a:t>
             </a:r>
-            <a:endParaRPr/>
           </a:p>
           <a:p>
-            <a:pPr indent="0" lvl="0" marL="0" marR="0" rtl="0" algn="l">
-              <a:spcBef>
-                <a:spcPts val="1500"/>
-              </a:spcBef>
-              <a:spcAft>
-                <a:spcPts val="0"/>
-              </a:spcAft>
-              <a:buNone/>
+            <a:pPr>
+              <a:spcBef>
+                <a:spcPts val="800"/>
+              </a:spcBef>
             </a:pPr>
             <a:r>
-              <a:rPr b="0" i="1" lang="en-US" sz="2000" u="none" cap="none" strike="noStrike">
+              <a:rPr sz="1600" i="1">
                 <a:solidFill>
                   <a:srgbClr val="333333"/>
                 </a:solidFill>
                 <a:latin typeface="Calibri"/>
-                <a:ea typeface="Calibri"/>
-                <a:cs typeface="Calibri"/>
-                <a:sym typeface="Calibri"/>
               </a:rPr>
               <a:t>"Hola, no me llega el email para recuperar mi contraseña. ¿Qué hago?"</a:t>
             </a:r>
-            <a:endParaRPr/>
           </a:p>
         </p:txBody>
       </p:sp>
       <p:sp>
         <p:nvSpPr>
-          <p:cNvPr id="180" name="Google Shape;180;p21"/>
+          <p:cNvPr id="180" name="Rounded Rectangle 179"/>
           <p:cNvSpPr/>
           <p:nvPr/>
         </p:nvSpPr>
         <p:spPr>
           <a:xfrm>
-            <a:off x="5669280" y="3566160"/>
-            <a:ext cx="731520" cy="731520"/>
+            <a:off x="6217920" y="1691640"/>
+            <a:ext cx="5486400" cy="1828800"/>
           </a:xfrm>
-          <a:prstGeom prst="rightArrow">
-            <a:avLst>
-              <a:gd fmla="val 50000" name="adj1"/>
-              <a:gd fmla="val 50000" name="adj2"/>
-            </a:avLst>
+          <a:prstGeom prst="roundRect">
+            <a:avLst/>
           </a:prstGeom>
           <a:solidFill>
             <a:srgbClr val="1F3A5F"/>
@@ -17772,374 +17703,272 @@
           <a:ln>
             <a:noFill/>
           </a:ln>
-          <a:effectLst>
-            <a:outerShdw blurRad="40000" rotWithShape="0" dir="5400000" dist="23000">
-              <a:srgbClr val="000000">
-                <a:alpha val="34901"/>
-              </a:srgbClr>
-            </a:outerShdw>
-          </a:effectLst>
         </p:spPr>
+        <p:style>
+          <a:lnRef idx="1">
+            <a:schemeClr val="accent1"/>
+          </a:lnRef>
+          <a:fillRef idx="3">
+            <a:schemeClr val="accent1"/>
+          </a:fillRef>
+          <a:effectRef idx="2">
+            <a:schemeClr val="accent1"/>
+          </a:effectRef>
+          <a:fontRef idx="minor">
+            <a:schemeClr val="lt1"/>
+          </a:fontRef>
+        </p:style>
         <p:txBody>
-          <a:bodyPr anchorCtr="0" anchor="ctr" bIns="45700" lIns="91425" spcFirstLastPara="1" rIns="91425" wrap="square" tIns="45700">
-            <a:noAutofit/>
-          </a:bodyPr>
+          <a:bodyPr rtlCol="0" anchor="ctr" lIns="190500" tIns="152400" wrap="square"/>
           <a:lstStyle/>
           <a:p>
-            <a:pPr indent="0" lvl="0" marL="0" marR="0" rtl="0" algn="ctr">
-              <a:spcBef>
-                <a:spcPts val="0"/>
-              </a:spcBef>
-              <a:spcAft>
-                <a:spcPts val="0"/>
-              </a:spcAft>
-              <a:buNone/>
+            <a:pPr algn="ctr"/>
+            <a:r>
+              <a:rPr sz="1300" b="1">
+                <a:solidFill>
+                  <a:srgbClr val="DD8A5C"/>
+                </a:solidFill>
+                <a:latin typeface="Calibri"/>
+              </a:rPr>
+              <a:t>🧠 Análisis interno (JSON validado)</a:t>
+            </a:r>
+          </a:p>
+          <a:p>
+            <a:pPr>
+              <a:spcBef>
+                <a:spcPts val="300"/>
+              </a:spcBef>
             </a:pPr>
             <a:r>
-              <a:t/>
+              <a:rPr sz="1200" b="1">
+                <a:solidFill>
+                  <a:srgbClr val="DD8A5C"/>
+                </a:solidFill>
+                <a:latin typeface="Consolas"/>
+              </a:rPr>
+              <a:t>intent: </a:t>
             </a:r>
-            <a:endParaRPr b="0" i="0" sz="1800" u="none" cap="none" strike="noStrike">
-              <a:solidFill>
-                <a:schemeClr val="dk1"/>
-              </a:solidFill>
-              <a:latin typeface="Calibri"/>
-              <a:ea typeface="Calibri"/>
-              <a:cs typeface="Calibri"/>
-              <a:sym typeface="Calibri"/>
-            </a:endParaRPr>
+            <a:r>
+              <a:rPr sz="1200">
+                <a:solidFill>
+                  <a:srgbClr val="FFFFFF"/>
+                </a:solidFill>
+                <a:latin typeface="Consolas"/>
+              </a:rPr>
+              <a:t>"Soporte de Cuenta"</a:t>
+            </a:r>
+          </a:p>
+          <a:p>
+            <a:pPr>
+              <a:spcBef>
+                <a:spcPts val="300"/>
+              </a:spcBef>
+            </a:pPr>
+            <a:r>
+              <a:rPr sz="1200" b="1">
+                <a:solidFill>
+                  <a:srgbClr val="DD8A5C"/>
+                </a:solidFill>
+                <a:latin typeface="Consolas"/>
+              </a:rPr>
+              <a:t>confidence: </a:t>
+            </a:r>
+            <a:r>
+              <a:rPr sz="1200">
+                <a:solidFill>
+                  <a:srgbClr val="FFFFFF"/>
+                </a:solidFill>
+                <a:latin typeface="Consolas"/>
+              </a:rPr>
+              <a:t>0.95</a:t>
+            </a:r>
+          </a:p>
+          <a:p>
+            <a:pPr>
+              <a:spcBef>
+                <a:spcPts val="300"/>
+              </a:spcBef>
+            </a:pPr>
+            <a:r>
+              <a:rPr sz="1200" b="1">
+                <a:solidFill>
+                  <a:srgbClr val="DD8A5C"/>
+                </a:solidFill>
+                <a:latin typeface="Consolas"/>
+              </a:rPr>
+              <a:t>urgency: </a:t>
+            </a:r>
+            <a:r>
+              <a:rPr sz="1200">
+                <a:solidFill>
+                  <a:srgbClr val="FFFFFF"/>
+                </a:solidFill>
+                <a:latin typeface="Consolas"/>
+              </a:rPr>
+              <a:t>"media"</a:t>
+            </a:r>
+          </a:p>
+          <a:p>
+            <a:pPr>
+              <a:spcBef>
+                <a:spcPts val="300"/>
+              </a:spcBef>
+            </a:pPr>
+            <a:r>
+              <a:rPr sz="1200" b="1">
+                <a:solidFill>
+                  <a:srgbClr val="DD8A5C"/>
+                </a:solidFill>
+                <a:latin typeface="Consolas"/>
+              </a:rPr>
+              <a:t>language: </a:t>
+            </a:r>
+            <a:r>
+              <a:rPr sz="1200">
+                <a:solidFill>
+                  <a:srgbClr val="FFFFFF"/>
+                </a:solidFill>
+                <a:latin typeface="Consolas"/>
+              </a:rPr>
+              <a:t>"es"</a:t>
+            </a:r>
           </a:p>
         </p:txBody>
       </p:sp>
       <p:sp>
         <p:nvSpPr>
-          <p:cNvPr id="181" name="Google Shape;181;p21"/>
+          <p:cNvPr id="181" name="Rounded Rectangle 180"/>
           <p:cNvSpPr/>
           <p:nvPr/>
         </p:nvSpPr>
         <p:spPr>
           <a:xfrm>
-            <a:off x="6583680" y="1828800"/>
-            <a:ext cx="5120640" cy="4114800"/>
+            <a:off x="457200" y="3703320"/>
+            <a:ext cx="11247120" cy="2194560"/>
           </a:xfrm>
           <a:prstGeom prst="roundRect">
-            <a:avLst>
-              <a:gd fmla="val 16667" name="adj"/>
-            </a:avLst>
+            <a:avLst/>
           </a:prstGeom>
           <a:solidFill>
-            <a:srgbClr val="1F3A5F"/>
+            <a:srgbClr val="DD8A5C"/>
           </a:solidFill>
           <a:ln>
             <a:noFill/>
           </a:ln>
-          <a:effectLst>
-            <a:outerShdw blurRad="40000" rotWithShape="0" dir="5400000" dist="23000">
-              <a:srgbClr val="000000">
-                <a:alpha val="34901"/>
-              </a:srgbClr>
-            </a:outerShdw>
-          </a:effectLst>
         </p:spPr>
+        <p:style>
+          <a:lnRef idx="1">
+            <a:schemeClr val="accent1"/>
+          </a:lnRef>
+          <a:fillRef idx="3">
+            <a:schemeClr val="accent1"/>
+          </a:fillRef>
+          <a:effectRef idx="2">
+            <a:schemeClr val="accent1"/>
+          </a:effectRef>
+          <a:fontRef idx="minor">
+            <a:schemeClr val="lt1"/>
+          </a:fontRef>
+        </p:style>
         <p:txBody>
-          <a:bodyPr anchorCtr="0" anchor="ctr" bIns="45700" lIns="190500" spcFirstLastPara="1" rIns="91425" wrap="square" tIns="190500">
-            <a:noAutofit/>
-          </a:bodyPr>
+          <a:bodyPr rtlCol="0" anchor="ctr" lIns="254000" tIns="152400" wrap="square"/>
           <a:lstStyle/>
           <a:p>
-            <a:pPr indent="0" lvl="0" marL="0" marR="0" rtl="0" algn="ctr">
-              <a:spcBef>
-                <a:spcPts val="0"/>
-              </a:spcBef>
-              <a:spcAft>
-                <a:spcPts val="0"/>
-              </a:spcAft>
-              <a:buNone/>
-            </a:pPr>
+            <a:pPr algn="ctr"/>
             <a:r>
-              <a:rPr b="1" i="0" lang="en-US" sz="1400" u="none" cap="none" strike="noStrike">
-                <a:solidFill>
-                  <a:srgbClr val="DD8A5C"/>
-                </a:solidFill>
-                <a:latin typeface="Calibri"/>
-                <a:ea typeface="Calibri"/>
-                <a:cs typeface="Calibri"/>
-                <a:sym typeface="Calibri"/>
-              </a:rPr>
-              <a:t>MailAnalysis (JSON validado)</a:t>
-            </a:r>
-            <a:endParaRPr/>
-          </a:p>
-          <a:p>
-            <a:pPr indent="0" lvl="0" marL="0" marR="0" rtl="0" algn="l">
-              <a:spcBef>
-                <a:spcPts val="600"/>
-              </a:spcBef>
-              <a:spcAft>
-                <a:spcPts val="0"/>
-              </a:spcAft>
-              <a:buNone/>
-            </a:pPr>
-            <a:r>
-              <a:rPr b="1" i="0" lang="en-US" sz="1300" u="none" cap="none" strike="noStrike">
-                <a:solidFill>
-                  <a:srgbClr val="DD8A5C"/>
-                </a:solidFill>
-                <a:latin typeface="Consolas"/>
-                <a:ea typeface="Consolas"/>
-                <a:cs typeface="Consolas"/>
-                <a:sym typeface="Consolas"/>
-              </a:rPr>
-              <a:t>intent: </a:t>
-            </a:r>
-            <a:r>
-              <a:rPr b="0" i="0" lang="en-US" sz="1300" u="none" cap="none" strike="noStrike">
+              <a:rPr sz="1300" b="1">
                 <a:solidFill>
                   <a:srgbClr val="FFFFFF"/>
                 </a:solidFill>
-                <a:latin typeface="Consolas"/>
-                <a:ea typeface="Consolas"/>
-                <a:cs typeface="Consolas"/>
-                <a:sym typeface="Consolas"/>
+                <a:latin typeface="Calibri"/>
               </a:rPr>
-              <a:t>"Soporte de Cuenta"</a:t>
+              <a:t>✉️  suggested_response (texto listo para enviar al cliente)</a:t>
             </a:r>
-            <a:endParaRPr/>
           </a:p>
           <a:p>
-            <a:pPr indent="0" lvl="0" marL="0" marR="0" rtl="0" algn="l">
-              <a:spcBef>
-                <a:spcPts val="600"/>
-              </a:spcBef>
-              <a:spcAft>
-                <a:spcPts val="0"/>
-              </a:spcAft>
-              <a:buNone/>
+            <a:pPr>
+              <a:spcBef>
+                <a:spcPts val="1000"/>
+              </a:spcBef>
             </a:pPr>
             <a:r>
-              <a:rPr b="1" i="0" lang="en-US" sz="1300" u="none" cap="none" strike="noStrike">
-                <a:solidFill>
-                  <a:srgbClr val="DD8A5C"/>
-                </a:solidFill>
-                <a:latin typeface="Consolas"/>
-                <a:ea typeface="Consolas"/>
-                <a:cs typeface="Consolas"/>
-                <a:sym typeface="Consolas"/>
-              </a:rPr>
-              <a:t>confidence: </a:t>
-            </a:r>
-            <a:r>
-              <a:rPr b="0" i="0" lang="en-US" sz="1300" u="none" cap="none" strike="noStrike">
+              <a:rPr sz="1400" i="1">
                 <a:solidFill>
                   <a:srgbClr val="FFFFFF"/>
                 </a:solidFill>
-                <a:latin typeface="Consolas"/>
-                <a:ea typeface="Consolas"/>
-                <a:cs typeface="Consolas"/>
-                <a:sym typeface="Consolas"/>
+                <a:latin typeface="Calibri"/>
               </a:rPr>
-              <a:t>0.95</a:t>
+              <a:t>"Hola, si no recibiste el email para recuperar tu contraseña, primero revisá la carpeta de spam. Si tampoco aparece allí, podés solicitarlo de nuevo desde shophive.example/reset-password. El link de recuperación es válido por 1 hora. Si después de 15 minutos seguís sin recibirlo, escribinos a support@shophive.example."</a:t>
             </a:r>
-            <a:endParaRPr/>
-          </a:p>
-          <a:p>
-            <a:pPr indent="0" lvl="0" marL="0" marR="0" rtl="0" algn="l">
-              <a:spcBef>
-                <a:spcPts val="600"/>
-              </a:spcBef>
-              <a:spcAft>
-                <a:spcPts val="0"/>
-              </a:spcAft>
-              <a:buNone/>
-            </a:pPr>
-            <a:r>
-              <a:rPr b="1" i="0" lang="en-US" sz="1300" u="none" cap="none" strike="noStrike">
-                <a:solidFill>
-                  <a:srgbClr val="DD8A5C"/>
-                </a:solidFill>
-                <a:latin typeface="Consolas"/>
-                <a:ea typeface="Consolas"/>
-                <a:cs typeface="Consolas"/>
-                <a:sym typeface="Consolas"/>
-              </a:rPr>
-              <a:t>urgency: </a:t>
-            </a:r>
-            <a:r>
-              <a:rPr b="0" i="0" lang="en-US" sz="1300" u="none" cap="none" strike="noStrike">
-                <a:solidFill>
-                  <a:srgbClr val="FFFFFF"/>
-                </a:solidFill>
-                <a:latin typeface="Consolas"/>
-                <a:ea typeface="Consolas"/>
-                <a:cs typeface="Consolas"/>
-                <a:sym typeface="Consolas"/>
-              </a:rPr>
-              <a:t>"media"</a:t>
-            </a:r>
-            <a:endParaRPr/>
-          </a:p>
-          <a:p>
-            <a:pPr indent="0" lvl="0" marL="0" marR="0" rtl="0" algn="l">
-              <a:spcBef>
-                <a:spcPts val="600"/>
-              </a:spcBef>
-              <a:spcAft>
-                <a:spcPts val="0"/>
-              </a:spcAft>
-              <a:buNone/>
-            </a:pPr>
-            <a:r>
-              <a:rPr b="1" i="0" lang="en-US" sz="1300" u="none" cap="none" strike="noStrike">
-                <a:solidFill>
-                  <a:srgbClr val="DD8A5C"/>
-                </a:solidFill>
-                <a:latin typeface="Consolas"/>
-                <a:ea typeface="Consolas"/>
-                <a:cs typeface="Consolas"/>
-                <a:sym typeface="Consolas"/>
-              </a:rPr>
-              <a:t>language: </a:t>
-            </a:r>
-            <a:r>
-              <a:rPr b="0" i="0" lang="en-US" sz="1300" u="none" cap="none" strike="noStrike">
-                <a:solidFill>
-                  <a:srgbClr val="FFFFFF"/>
-                </a:solidFill>
-                <a:latin typeface="Consolas"/>
-                <a:ea typeface="Consolas"/>
-                <a:cs typeface="Consolas"/>
-                <a:sym typeface="Consolas"/>
-              </a:rPr>
-              <a:t>"es"</a:t>
-            </a:r>
-            <a:endParaRPr/>
-          </a:p>
-          <a:p>
-            <a:pPr indent="0" lvl="0" marL="0" marR="0" rtl="0" algn="l">
-              <a:spcBef>
-                <a:spcPts val="600"/>
-              </a:spcBef>
-              <a:spcAft>
-                <a:spcPts val="0"/>
-              </a:spcAft>
-              <a:buNone/>
-            </a:pPr>
-            <a:r>
-              <a:rPr b="1" i="0" lang="en-US" sz="1300" u="none" cap="none" strike="noStrike">
-                <a:solidFill>
-                  <a:srgbClr val="DD8A5C"/>
-                </a:solidFill>
-                <a:latin typeface="Consolas"/>
-                <a:ea typeface="Consolas"/>
-                <a:cs typeface="Consolas"/>
-                <a:sym typeface="Consolas"/>
-              </a:rPr>
-              <a:t>summary: </a:t>
-            </a:r>
-            <a:r>
-              <a:rPr b="0" i="0" lang="en-US" sz="1300" u="none" cap="none" strike="noStrike">
-                <a:solidFill>
-                  <a:srgbClr val="FFFFFF"/>
-                </a:solidFill>
-                <a:latin typeface="Consolas"/>
-                <a:ea typeface="Consolas"/>
-                <a:cs typeface="Consolas"/>
-                <a:sym typeface="Consolas"/>
-              </a:rPr>
-              <a:t>"Cliente reporta no recibir el email de recuperación..."</a:t>
-            </a:r>
-            <a:endParaRPr/>
-          </a:p>
-          <a:p>
-            <a:pPr indent="0" lvl="0" marL="0" marR="0" rtl="0" algn="l">
-              <a:spcBef>
-                <a:spcPts val="600"/>
-              </a:spcBef>
-              <a:spcAft>
-                <a:spcPts val="0"/>
-              </a:spcAft>
-              <a:buNone/>
-            </a:pPr>
-            <a:r>
-              <a:rPr b="1" i="0" lang="en-US" sz="1300" u="none" cap="none" strike="noStrike">
-                <a:solidFill>
-                  <a:srgbClr val="DD8A5C"/>
-                </a:solidFill>
-                <a:latin typeface="Consolas"/>
-                <a:ea typeface="Consolas"/>
-                <a:cs typeface="Consolas"/>
-                <a:sym typeface="Consolas"/>
-              </a:rPr>
-              <a:t>sources: </a:t>
-            </a:r>
-            <a:r>
-              <a:rPr b="0" i="0" lang="en-US" sz="1300" u="none" cap="none" strike="noStrike">
-                <a:solidFill>
-                  <a:srgbClr val="FFFFFF"/>
-                </a:solidFill>
-                <a:latin typeface="Consolas"/>
-                <a:ea typeface="Consolas"/>
-                <a:cs typeface="Consolas"/>
-                <a:sym typeface="Consolas"/>
-              </a:rPr>
-              <a:t>["account_recuperar-contrasena-es__0"]</a:t>
-            </a:r>
-            <a:endParaRPr/>
           </a:p>
         </p:txBody>
       </p:sp>
       <p:sp>
         <p:nvSpPr>
-          <p:cNvPr id="182" name="Google Shape;182;p21"/>
-          <p:cNvSpPr txBox="1"/>
+          <p:cNvPr id="182" name="Rounded Rectangle 181"/>
+          <p:cNvSpPr/>
           <p:nvPr/>
         </p:nvSpPr>
         <p:spPr>
           <a:xfrm>
-            <a:off x="457200" y="6126480"/>
-            <a:ext cx="11247120" cy="365760"/>
+            <a:off x="457200" y="6035040"/>
+            <a:ext cx="11247120" cy="457200"/>
           </a:xfrm>
-          <a:prstGeom prst="rect">
+          <a:prstGeom prst="roundRect">
             <a:avLst/>
           </a:prstGeom>
-          <a:noFill/>
+          <a:solidFill>
+            <a:srgbClr val="F5F5F5"/>
+          </a:solidFill>
           <a:ln>
-            <a:noFill/>
+            <a:solidFill>
+              <a:srgbClr val="CCCCCC"/>
+            </a:solidFill>
           </a:ln>
         </p:spPr>
+        <p:style>
+          <a:lnRef idx="1">
+            <a:schemeClr val="accent1"/>
+          </a:lnRef>
+          <a:fillRef idx="3">
+            <a:schemeClr val="accent1"/>
+          </a:fillRef>
+          <a:effectRef idx="2">
+            <a:schemeClr val="accent1"/>
+          </a:effectRef>
+          <a:fontRef idx="minor">
+            <a:schemeClr val="lt1"/>
+          </a:fontRef>
+        </p:style>
         <p:txBody>
-          <a:bodyPr anchorCtr="0" anchor="t" bIns="0" lIns="0" spcFirstLastPara="1" rIns="0" wrap="square" tIns="0">
-            <a:spAutoFit/>
-          </a:bodyPr>
+          <a:bodyPr rtlCol="0" anchor="ctr" lIns="190500"/>
           <a:lstStyle/>
           <a:p>
-            <a:pPr indent="0" lvl="0" marL="0" marR="0" rtl="0" algn="l">
-              <a:spcBef>
-                <a:spcPts val="0"/>
-              </a:spcBef>
-              <a:spcAft>
-                <a:spcPts val="0"/>
-              </a:spcAft>
-              <a:buNone/>
-            </a:pPr>
+            <a:pPr algn="ctr"/>
             <a:r>
-              <a:rPr b="1" i="1" lang="en-US" sz="1400" u="none" cap="none" strike="noStrike">
+              <a:rPr sz="1200" b="1">
                 <a:solidFill>
                   <a:srgbClr val="1F3A5F"/>
                 </a:solidFill>
                 <a:latin typeface="Calibri"/>
-                <a:ea typeface="Calibri"/>
-                <a:cs typeface="Calibri"/>
-                <a:sym typeface="Calibri"/>
               </a:rPr>
-              <a:t>El sistema cita la fuente exacta del KB — trazabilidad total para auditoría.</a:t>
+              <a:t>🔗 sources: </a:t>
             </a:r>
-            <a:endParaRPr/>
+            <a:r>
+              <a:rPr sz="1200">
+                <a:solidFill>
+                  <a:srgbClr val="333333"/>
+                </a:solidFill>
+                <a:latin typeface="Calibri"/>
+              </a:rPr>
+              <a:t>["account_recuperar-contrasena-es__0"]   →  trazabilidad total: cada respuesta cita la FAQ que la fundamenta.</a:t>
+            </a:r>
           </a:p>
         </p:txBody>
       </p:sp>
       <p:sp>
         <p:nvSpPr>
-          <p:cNvPr id="183" name="Google Shape;183;p21"/>
+          <p:cNvPr id="183" name="TextBox 182"/>
           <p:cNvSpPr txBox="1"/>
           <p:nvPr/>
         </p:nvSpPr>
@@ -18152,38 +17981,23 @@
             <a:avLst/>
           </a:prstGeom>
           <a:noFill/>
-          <a:ln>
-            <a:noFill/>
-          </a:ln>
         </p:spPr>
         <p:txBody>
-          <a:bodyPr anchorCtr="0" anchor="t" bIns="0" lIns="0" spcFirstLastPara="1" rIns="0" wrap="square" tIns="0">
+          <a:bodyPr wrap="square" lIns="0" rIns="0" tIns="0" bIns="0">
             <a:spAutoFit/>
           </a:bodyPr>
           <a:lstStyle/>
           <a:p>
-            <a:pPr indent="0" lvl="0" marL="0" marR="0" rtl="0" algn="l">
-              <a:spcBef>
-                <a:spcPts val="0"/>
-              </a:spcBef>
-              <a:spcAft>
-                <a:spcPts val="0"/>
-              </a:spcAft>
-              <a:buNone/>
-            </a:pPr>
+            <a:pPr algn="l"/>
             <a:r>
-              <a:rPr b="0" i="1" lang="en-US" sz="1000" u="none" cap="none" strike="noStrike">
+              <a:rPr sz="1000" b="0" i="1">
                 <a:solidFill>
                   <a:srgbClr val="777777"/>
                 </a:solidFill>
                 <a:latin typeface="Calibri"/>
-                <a:ea typeface="Calibri"/>
-                <a:cs typeface="Calibri"/>
-                <a:sym typeface="Calibri"/>
               </a:rPr>
               <a:t>Slide 9 / 12</a:t>
             </a:r>
-            <a:endParaRPr/>
           </a:p>
         </p:txBody>
       </p:sp>

</xml_diff>